<commit_message>
Update author name to Zuhair Syd
</commit_message>
<xml_diff>
--- a/tabular/Student_Stress_Profiles_Presentation.pptx
+++ b/tabular/Student_Stress_Profiles_Presentation.pptx
@@ -3231,7 +3231,7 @@
               </a:defRPr>
             </a:pPr>
             <a:r>
-              <a:t>Zuhair Hussain (Solo Presentation · Assisted by Google Gemini) · Dr. Masoud Rostami · Fall 2026</a:t>
+              <a:t>Zuhair Syd (Solo Presentation · Assisted by Google Gemini) · Dr. Masoud Rostami · Fall 2026</a:t>
             </a:r>
           </a:p>
         </p:txBody>
@@ -7789,7 +7789,7 @@
               </a:defRPr>
             </a:pPr>
             <a:r>
-              <a:t>Executed independently by Zuhair Hussain with AI pair-programming support from Google Gemini for rapid code prototyping, script automation, visualization styling, and LaTeX formatting. All analytical methodologies, data validation, and clinical interpretations verified and reproducible in the accompanying Jupyter notebook.</a:t>
+              <a:t>Executed independently by Zuhair Syd with AI pair-programming support from Google Gemini for rapid code prototyping, script automation, visualization styling, and LaTeX formatting. All analytical methodologies, data validation, and clinical interpretations verified and reproducible in the accompanying Jupyter notebook.</a:t>
             </a:r>
           </a:p>
         </p:txBody>

</xml_diff>